<commit_message>
Auto-open contact form on #contact, polish PPT slides 5/7/10
- CTASection now opens the inquiry form automatically (and scrolls to
  it) when the page loads or navigates to #contact, instead of
  requiring an extra click on the "상담 문의하기" prompt button first
- Rebuild company-profile.pptx: slides 5 and 7's 3 remaining cards
  (after removing the unused 4th card slot) are now evenly re-spaced
  to fill the full row width instead of leaving an empty gap on the
  right; slide 10's approximated bar chart is replaced with a native
  PowerPoint doughnut chart (공공부문 108 / 민간부문 42) with proper
  data labels and legend

Co-Authored-By: Claude Sonnet 5 <noreply@anthropic.com>
</commit_message>
<xml_diff>
--- a/public/company-profile.pptx
+++ b/public/company-profile.pptx
@@ -132,6 +132,139 @@
     </p:ext>
   </p:extLst>
 </p:presentation>
+</file>
+
+<file path=ppt/charts/chart1.xml><?xml version="1.0" encoding="utf-8"?>
+<c:chartSpace xmlns:c="http://schemas.openxmlformats.org/drawingml/2006/chart" xmlns:a="http://schemas.openxmlformats.org/drawingml/2006/main" xmlns:r="http://schemas.openxmlformats.org/officeDocument/2006/relationships">
+  <c:date1904 val="0"/>
+  <c:roundedCorners val="0"/>
+  <c:chart>
+    <c:autoTitleDeleted val="1"/>
+    <c:plotArea>
+      <c:layout/>
+      <c:doughnutChart>
+        <c:varyColors val="1"/>
+        <c:ser>
+          <c:idx val="0"/>
+          <c:order val="0"/>
+          <c:tx>
+            <c:strRef>
+              <c:f>Sheet1!$B$1</c:f>
+              <c:strCache>
+                <c:ptCount val="1"/>
+                <c:pt idx="0">
+                  <c:v>Series 1</c:v>
+                </c:pt>
+              </c:strCache>
+            </c:strRef>
+          </c:tx>
+          <c:dPt>
+            <c:idx val="0"/>
+            <c:spPr>
+              <a:solidFill>
+                <a:srgbClr val="0B2545"/>
+              </a:solidFill>
+            </c:spPr>
+          </c:dPt>
+          <c:dPt>
+            <c:idx val="1"/>
+            <c:spPr>
+              <a:solidFill>
+                <a:srgbClr val="B8933E"/>
+              </a:solidFill>
+            </c:spPr>
+          </c:dPt>
+          <c:cat>
+            <c:strRef>
+              <c:f>Sheet1!$A$2:$A$3</c:f>
+              <c:strCache>
+                <c:ptCount val="2"/>
+                <c:pt idx="0">
+                  <c:v>공공부문</c:v>
+                </c:pt>
+                <c:pt idx="1">
+                  <c:v>민간부문</c:v>
+                </c:pt>
+              </c:strCache>
+            </c:strRef>
+          </c:cat>
+          <c:val>
+            <c:numRef>
+              <c:f>Sheet1!$B$2:$B$3</c:f>
+              <c:numCache>
+                <c:formatCode>General</c:formatCode>
+                <c:ptCount val="2"/>
+                <c:pt idx="0">
+                  <c:v>108</c:v>
+                </c:pt>
+                <c:pt idx="1">
+                  <c:v>42</c:v>
+                </c:pt>
+              </c:numCache>
+            </c:numRef>
+          </c:val>
+        </c:ser>
+        <c:dLbls>
+          <c:numFmt formatCode="0" sourceLinked="0"/>
+          <c:txPr>
+            <a:bodyPr/>
+            <a:lstStyle/>
+            <a:p>
+              <a:pPr>
+                <a:defRPr sz="1800" b="1">
+                  <a:solidFill>
+                    <a:srgbClr val="FFFFFF"/>
+                  </a:solidFill>
+                </a:defRPr>
+              </a:pPr>
+            </a:p>
+          </c:txPr>
+          <c:showLegendKey val="0"/>
+          <c:showVal val="1"/>
+          <c:showCatName val="0"/>
+          <c:showSerName val="0"/>
+          <c:showPercent val="0"/>
+          <c:showBubbleSize val="0"/>
+          <c:showLeaderLines val="1"/>
+        </c:dLbls>
+        <c:firstSliceAng val="0"/>
+        <c:holeSize val="50"/>
+      </c:doughnutChart>
+    </c:plotArea>
+    <c:legend>
+      <c:legendPos val="b"/>
+      <c:layout/>
+      <c:overlay val="0"/>
+      <c:txPr>
+        <a:bodyPr/>
+        <a:lstStyle/>
+        <a:p>
+          <a:pPr>
+            <a:defRPr sz="1400">
+              <a:latin typeface="Pretendard"/>
+            </a:defRPr>
+          </a:pPr>
+        </a:p>
+      </c:txPr>
+    </c:legend>
+    <c:plotVisOnly val="1"/>
+    <c:dispBlanksAs val="gap"/>
+    <c:showDLblsOverMax val="0"/>
+  </c:chart>
+  <c:txPr>
+    <a:bodyPr/>
+    <a:lstStyle/>
+    <a:p>
+      <a:pPr>
+        <a:defRPr sz="1800"/>
+      </a:pPr>
+      <a:endParaRPr/>
+    </a:p>
+  </c:txPr>
+  <c:externalData r:id="rId1">
+    <c:autoUpdate val="0"/>
+  </c:externalData>
+</c:chartSpace>
 </file>
 
 <file path=ppt/slideLayouts/slideLayout1.xml><?xml version="1.0" encoding="utf-8"?>
@@ -4053,53 +4186,14 @@
       </p:sp>
       <p:sp>
         <p:nvSpPr>
-          <p:cNvPr id="4" name="TextBox 3"/>
-          <p:cNvSpPr txBox="1"/>
-          <p:nvPr/>
-        </p:nvSpPr>
-        <p:spPr>
-          <a:xfrm>
-            <a:off x="822960" y="2148840"/>
-            <a:ext cx="1280160" cy="475488"/>
-          </a:xfrm>
-          <a:prstGeom prst="rect">
-            <a:avLst/>
-          </a:prstGeom>
-          <a:noFill/>
-        </p:spPr>
-        <p:txBody>
-          <a:bodyPr wrap="square" lIns="0" tIns="12700" rIns="0" bIns="12700" anchor="ctr">
-            <a:spAutoFit/>
-          </a:bodyPr>
-          <a:lstStyle/>
-          <a:p>
-            <a:pPr algn="r">
-              <a:lnSpc>
-                <a:spcPct val="105000"/>
-              </a:lnSpc>
-            </a:pPr>
-            <a:r>
-              <a:rPr sz="1100" b="1">
-                <a:solidFill>
-                  <a:srgbClr val="1A1A1A"/>
-                </a:solidFill>
-                <a:latin typeface="Pretendard"/>
-              </a:rPr>
-              <a:t>공공부문</a:t>
-            </a:r>
-          </a:p>
-        </p:txBody>
-      </p:sp>
-      <p:sp>
-        <p:nvSpPr>
-          <p:cNvPr id="5" name="Rectangle 4"/>
+          <p:cNvPr id="23" name="Rectangle 22"/>
           <p:cNvSpPr/>
           <p:nvPr/>
         </p:nvSpPr>
         <p:spPr>
           <a:xfrm>
-            <a:off x="2194560" y="2249424"/>
-            <a:ext cx="8412480" cy="274320"/>
+            <a:off x="457200" y="5760720"/>
+            <a:ext cx="73152" cy="457200"/>
           </a:xfrm>
           <a:prstGeom prst="rect">
             <a:avLst/>
@@ -4137,258 +4231,6 @@
       </p:sp>
       <p:sp>
         <p:nvSpPr>
-          <p:cNvPr id="6" name="TextBox 5"/>
-          <p:cNvSpPr txBox="1"/>
-          <p:nvPr/>
-        </p:nvSpPr>
-        <p:spPr>
-          <a:xfrm>
-            <a:off x="10698480" y="2148840"/>
-            <a:ext cx="1097280" cy="475488"/>
-          </a:xfrm>
-          <a:prstGeom prst="rect">
-            <a:avLst/>
-          </a:prstGeom>
-          <a:noFill/>
-        </p:spPr>
-        <p:txBody>
-          <a:bodyPr wrap="square" lIns="0" tIns="12700" rIns="0" bIns="12700" anchor="ctr">
-            <a:spAutoFit/>
-          </a:bodyPr>
-          <a:lstStyle/>
-          <a:p>
-            <a:pPr algn="l">
-              <a:lnSpc>
-                <a:spcPct val="105000"/>
-              </a:lnSpc>
-            </a:pPr>
-            <a:r>
-              <a:rPr sz="1100" b="1">
-                <a:solidFill>
-                  <a:srgbClr val="0B3041"/>
-                </a:solidFill>
-                <a:latin typeface="Pretendard"/>
-              </a:rPr>
-              <a:t>108</a:t>
-            </a:r>
-          </a:p>
-        </p:txBody>
-      </p:sp>
-      <p:sp>
-        <p:nvSpPr>
-          <p:cNvPr id="7" name="TextBox 6"/>
-          <p:cNvSpPr txBox="1"/>
-          <p:nvPr/>
-        </p:nvSpPr>
-        <p:spPr>
-          <a:xfrm>
-            <a:off x="822960" y="2624328"/>
-            <a:ext cx="1280160" cy="475488"/>
-          </a:xfrm>
-          <a:prstGeom prst="rect">
-            <a:avLst/>
-          </a:prstGeom>
-          <a:noFill/>
-        </p:spPr>
-        <p:txBody>
-          <a:bodyPr wrap="square" lIns="0" tIns="12700" rIns="0" bIns="12700" anchor="ctr">
-            <a:spAutoFit/>
-          </a:bodyPr>
-          <a:lstStyle/>
-          <a:p>
-            <a:pPr algn="r">
-              <a:lnSpc>
-                <a:spcPct val="105000"/>
-              </a:lnSpc>
-            </a:pPr>
-            <a:r>
-              <a:rPr sz="1100" b="1">
-                <a:solidFill>
-                  <a:srgbClr val="1A1A1A"/>
-                </a:solidFill>
-                <a:latin typeface="Pretendard"/>
-              </a:rPr>
-              <a:t>민간부문</a:t>
-            </a:r>
-          </a:p>
-        </p:txBody>
-      </p:sp>
-      <p:sp>
-        <p:nvSpPr>
-          <p:cNvPr id="8" name="Rectangle 7"/>
-          <p:cNvSpPr/>
-          <p:nvPr/>
-        </p:nvSpPr>
-        <p:spPr>
-          <a:xfrm>
-            <a:off x="2194560" y="2724912"/>
-            <a:ext cx="6440804" cy="274320"/>
-          </a:xfrm>
-          <a:prstGeom prst="rect">
-            <a:avLst/>
-          </a:prstGeom>
-          <a:solidFill>
-            <a:srgbClr val="0B3041"/>
-          </a:solidFill>
-          <a:ln>
-            <a:noFill/>
-          </a:ln>
-          <a:effectLst/>
-        </p:spPr>
-        <p:style>
-          <a:lnRef idx="1">
-            <a:schemeClr val="accent1"/>
-          </a:lnRef>
-          <a:fillRef idx="3">
-            <a:schemeClr val="accent1"/>
-          </a:fillRef>
-          <a:effectRef idx="2">
-            <a:schemeClr val="accent1"/>
-          </a:effectRef>
-          <a:fontRef idx="minor">
-            <a:schemeClr val="lt1"/>
-          </a:fontRef>
-        </p:style>
-        <p:txBody>
-          <a:bodyPr rtlCol="0" anchor="ctr"/>
-          <a:lstStyle/>
-          <a:p>
-            <a:pPr algn="ctr"/>
-            <a:endParaRPr/>
-          </a:p>
-        </p:txBody>
-      </p:sp>
-      <p:sp>
-        <p:nvSpPr>
-          <p:cNvPr id="9" name="TextBox 8"/>
-          <p:cNvSpPr txBox="1"/>
-          <p:nvPr/>
-        </p:nvSpPr>
-        <p:spPr>
-          <a:xfrm>
-            <a:off x="8726805" y="2624328"/>
-            <a:ext cx="1097280" cy="475488"/>
-          </a:xfrm>
-          <a:prstGeom prst="rect">
-            <a:avLst/>
-          </a:prstGeom>
-          <a:noFill/>
-        </p:spPr>
-        <p:txBody>
-          <a:bodyPr wrap="square" lIns="0" tIns="12700" rIns="0" bIns="12700" anchor="ctr">
-            <a:spAutoFit/>
-          </a:bodyPr>
-          <a:lstStyle/>
-          <a:p>
-            <a:pPr algn="l">
-              <a:lnSpc>
-                <a:spcPct val="105000"/>
-              </a:lnSpc>
-            </a:pPr>
-            <a:r>
-              <a:rPr sz="1100" b="1">
-                <a:solidFill>
-                  <a:srgbClr val="0B3041"/>
-                </a:solidFill>
-                <a:latin typeface="Pretendard"/>
-              </a:rPr>
-              <a:t>42</a:t>
-            </a:r>
-          </a:p>
-        </p:txBody>
-      </p:sp>
-      <p:sp>
-        <p:nvSpPr>
-          <p:cNvPr id="22" name="Rectangle 21"/>
-          <p:cNvSpPr/>
-          <p:nvPr/>
-        </p:nvSpPr>
-        <p:spPr>
-          <a:xfrm>
-            <a:off x="2185416" y="2148840"/>
-            <a:ext cx="13716" cy="2852928"/>
-          </a:xfrm>
-          <a:prstGeom prst="rect">
-            <a:avLst/>
-          </a:prstGeom>
-          <a:solidFill>
-            <a:srgbClr val="D9D9D9"/>
-          </a:solidFill>
-          <a:ln>
-            <a:noFill/>
-          </a:ln>
-          <a:effectLst/>
-        </p:spPr>
-        <p:style>
-          <a:lnRef idx="1">
-            <a:schemeClr val="accent1"/>
-          </a:lnRef>
-          <a:fillRef idx="3">
-            <a:schemeClr val="accent1"/>
-          </a:fillRef>
-          <a:effectRef idx="2">
-            <a:schemeClr val="accent1"/>
-          </a:effectRef>
-          <a:fontRef idx="minor">
-            <a:schemeClr val="lt1"/>
-          </a:fontRef>
-        </p:style>
-        <p:txBody>
-          <a:bodyPr rtlCol="0" anchor="ctr"/>
-          <a:lstStyle/>
-          <a:p>
-            <a:pPr algn="ctr"/>
-            <a:endParaRPr/>
-          </a:p>
-        </p:txBody>
-      </p:sp>
-      <p:sp>
-        <p:nvSpPr>
-          <p:cNvPr id="23" name="Rectangle 22"/>
-          <p:cNvSpPr/>
-          <p:nvPr/>
-        </p:nvSpPr>
-        <p:spPr>
-          <a:xfrm>
-            <a:off x="457200" y="5760720"/>
-            <a:ext cx="73152" cy="457200"/>
-          </a:xfrm>
-          <a:prstGeom prst="rect">
-            <a:avLst/>
-          </a:prstGeom>
-          <a:solidFill>
-            <a:srgbClr val="0B3041"/>
-          </a:solidFill>
-          <a:ln>
-            <a:noFill/>
-          </a:ln>
-          <a:effectLst/>
-        </p:spPr>
-        <p:style>
-          <a:lnRef idx="1">
-            <a:schemeClr val="accent1"/>
-          </a:lnRef>
-          <a:fillRef idx="3">
-            <a:schemeClr val="accent1"/>
-          </a:fillRef>
-          <a:effectRef idx="2">
-            <a:schemeClr val="accent1"/>
-          </a:effectRef>
-          <a:fontRef idx="minor">
-            <a:schemeClr val="lt1"/>
-          </a:fontRef>
-        </p:style>
-        <p:txBody>
-          <a:bodyPr rtlCol="0" anchor="ctr"/>
-          <a:lstStyle/>
-          <a:p>
-            <a:pPr algn="ctr"/>
-            <a:endParaRPr/>
-          </a:p>
-        </p:txBody>
-      </p:sp>
-      <p:sp>
-        <p:nvSpPr>
           <p:cNvPr id="24" name="TextBox 23"/>
           <p:cNvSpPr txBox="1"/>
           <p:nvPr/>
@@ -4465,6 +4307,24 @@
           </a:p>
         </p:txBody>
       </p:sp>
+      <p:graphicFrame>
+        <p:nvGraphicFramePr>
+          <p:cNvPr id="26" name="Chart 25"/>
+          <p:cNvGraphicFramePr>
+            <a:graphicFrameLocks noGrp="1"/>
+          </p:cNvGraphicFramePr>
+          <p:nvPr/>
+        </p:nvGraphicFramePr>
+        <p:xfrm>
+          <a:off x="3355848" y="1691640"/>
+          <a:ext cx="5486400" cy="4206240"/>
+        </p:xfrm>
+        <a:graphic>
+          <a:graphicData uri="http://schemas.openxmlformats.org/drawingml/2006/chart">
+            <c:chart xmlns:c="http://schemas.openxmlformats.org/drawingml/2006/chart" r:id="rId2"/>
+          </a:graphicData>
+        </a:graphic>
+      </p:graphicFrame>
     </p:spTree>
   </p:cSld>
   <p:clrMapOvr>
@@ -12867,7 +12727,7 @@
         <p:spPr>
           <a:xfrm>
             <a:off x="457200" y="1842516"/>
-            <a:ext cx="2743200" cy="960120"/>
+            <a:ext cx="3611880" cy="960120"/>
           </a:xfrm>
           <a:prstGeom prst="rect">
             <a:avLst/>
@@ -12912,7 +12772,7 @@
         <p:spPr>
           <a:xfrm>
             <a:off x="457200" y="1888236"/>
-            <a:ext cx="2743200" cy="457200"/>
+            <a:ext cx="3611880" cy="457200"/>
           </a:xfrm>
           <a:prstGeom prst="rect">
             <a:avLst/>
@@ -12956,7 +12816,7 @@
         <p:spPr>
           <a:xfrm>
             <a:off x="457200" y="2482596"/>
-            <a:ext cx="2743200" cy="274320"/>
+            <a:ext cx="3611880" cy="274320"/>
           </a:xfrm>
           <a:prstGeom prst="rect">
             <a:avLst/>
@@ -13000,7 +12860,7 @@
         <p:spPr>
           <a:xfrm>
             <a:off x="457200" y="2802636"/>
-            <a:ext cx="2743200" cy="2880360"/>
+            <a:ext cx="3611880" cy="2880360"/>
           </a:xfrm>
           <a:prstGeom prst="rect">
             <a:avLst/>
@@ -13046,8 +12906,8 @@
         </p:nvSpPr>
         <p:spPr>
           <a:xfrm>
-            <a:off x="594360" y="2939796"/>
-            <a:ext cx="2468880" cy="365760"/>
+            <a:off x="637794" y="2939796"/>
+            <a:ext cx="3250692" cy="365760"/>
           </a:xfrm>
           <a:prstGeom prst="rect">
             <a:avLst/>
@@ -13090,8 +12950,8 @@
         </p:nvSpPr>
         <p:spPr>
           <a:xfrm>
-            <a:off x="594360" y="3351276"/>
-            <a:ext cx="2468880" cy="640080"/>
+            <a:off x="637794" y="3351276"/>
+            <a:ext cx="3250692" cy="640080"/>
           </a:xfrm>
           <a:prstGeom prst="rect">
             <a:avLst/>
@@ -13134,8 +12994,8 @@
         </p:nvSpPr>
         <p:spPr>
           <a:xfrm>
-            <a:off x="594360" y="4174236"/>
-            <a:ext cx="2468880" cy="228600"/>
+            <a:off x="637794" y="4174236"/>
+            <a:ext cx="3250692" cy="228600"/>
           </a:xfrm>
           <a:prstGeom prst="rect">
             <a:avLst/>
@@ -13178,8 +13038,8 @@
         </p:nvSpPr>
         <p:spPr>
           <a:xfrm>
-            <a:off x="594360" y="4448556"/>
-            <a:ext cx="2468880" cy="365760"/>
+            <a:off x="637794" y="4448556"/>
+            <a:ext cx="3250692" cy="365760"/>
           </a:xfrm>
           <a:prstGeom prst="rect">
             <a:avLst/>
@@ -13222,8 +13082,8 @@
         </p:nvSpPr>
         <p:spPr>
           <a:xfrm>
-            <a:off x="594360" y="4814316"/>
-            <a:ext cx="2468880" cy="365760"/>
+            <a:off x="637794" y="4814316"/>
+            <a:ext cx="3250692" cy="365760"/>
           </a:xfrm>
           <a:prstGeom prst="rect">
             <a:avLst/>
@@ -13266,8 +13126,8 @@
         </p:nvSpPr>
         <p:spPr>
           <a:xfrm>
-            <a:off x="594360" y="5180076"/>
-            <a:ext cx="2468880" cy="365760"/>
+            <a:off x="637794" y="5180076"/>
+            <a:ext cx="3250692" cy="365760"/>
           </a:xfrm>
           <a:prstGeom prst="rect">
             <a:avLst/>
@@ -13310,8 +13170,8 @@
         </p:nvSpPr>
         <p:spPr>
           <a:xfrm>
-            <a:off x="3291840" y="1842516"/>
-            <a:ext cx="2743200" cy="960120"/>
+            <a:off x="4274820" y="1842516"/>
+            <a:ext cx="3611880" cy="960120"/>
           </a:xfrm>
           <a:prstGeom prst="rect">
             <a:avLst/>
@@ -13355,8 +13215,8 @@
         </p:nvSpPr>
         <p:spPr>
           <a:xfrm>
-            <a:off x="3291840" y="1888236"/>
-            <a:ext cx="2743200" cy="457200"/>
+            <a:off x="4274820" y="1888236"/>
+            <a:ext cx="3611880" cy="457200"/>
           </a:xfrm>
           <a:prstGeom prst="rect">
             <a:avLst/>
@@ -13399,8 +13259,8 @@
         </p:nvSpPr>
         <p:spPr>
           <a:xfrm>
-            <a:off x="3291840" y="2482596"/>
-            <a:ext cx="2743200" cy="274320"/>
+            <a:off x="4274820" y="2482596"/>
+            <a:ext cx="3611880" cy="274320"/>
           </a:xfrm>
           <a:prstGeom prst="rect">
             <a:avLst/>
@@ -13443,8 +13303,8 @@
         </p:nvSpPr>
         <p:spPr>
           <a:xfrm>
-            <a:off x="3291840" y="2802636"/>
-            <a:ext cx="2743200" cy="2880360"/>
+            <a:off x="4274820" y="2802636"/>
+            <a:ext cx="3611880" cy="2880360"/>
           </a:xfrm>
           <a:prstGeom prst="rect">
             <a:avLst/>
@@ -13490,8 +13350,8 @@
         </p:nvSpPr>
         <p:spPr>
           <a:xfrm>
-            <a:off x="3429000" y="2939796"/>
-            <a:ext cx="2468880" cy="365760"/>
+            <a:off x="4455414" y="2939796"/>
+            <a:ext cx="3250692" cy="365760"/>
           </a:xfrm>
           <a:prstGeom prst="rect">
             <a:avLst/>
@@ -13534,8 +13394,8 @@
         </p:nvSpPr>
         <p:spPr>
           <a:xfrm>
-            <a:off x="3429000" y="3351276"/>
-            <a:ext cx="2468880" cy="640080"/>
+            <a:off x="4455414" y="3351276"/>
+            <a:ext cx="3250692" cy="640080"/>
           </a:xfrm>
           <a:prstGeom prst="rect">
             <a:avLst/>
@@ -13578,8 +13438,8 @@
         </p:nvSpPr>
         <p:spPr>
           <a:xfrm>
-            <a:off x="3429000" y="4174236"/>
-            <a:ext cx="2468880" cy="228600"/>
+            <a:off x="4455414" y="4174236"/>
+            <a:ext cx="3250692" cy="228600"/>
           </a:xfrm>
           <a:prstGeom prst="rect">
             <a:avLst/>
@@ -13622,8 +13482,8 @@
         </p:nvSpPr>
         <p:spPr>
           <a:xfrm>
-            <a:off x="3429000" y="4448556"/>
-            <a:ext cx="2468880" cy="365760"/>
+            <a:off x="4455414" y="4448556"/>
+            <a:ext cx="3250692" cy="365760"/>
           </a:xfrm>
           <a:prstGeom prst="rect">
             <a:avLst/>
@@ -13666,8 +13526,8 @@
         </p:nvSpPr>
         <p:spPr>
           <a:xfrm>
-            <a:off x="3429000" y="4814316"/>
-            <a:ext cx="2468880" cy="365760"/>
+            <a:off x="4455414" y="4814316"/>
+            <a:ext cx="3250692" cy="365760"/>
           </a:xfrm>
           <a:prstGeom prst="rect">
             <a:avLst/>
@@ -13710,8 +13570,8 @@
         </p:nvSpPr>
         <p:spPr>
           <a:xfrm>
-            <a:off x="3429000" y="5180076"/>
-            <a:ext cx="2468880" cy="365760"/>
+            <a:off x="4455414" y="5180076"/>
+            <a:ext cx="3250692" cy="365760"/>
           </a:xfrm>
           <a:prstGeom prst="rect">
             <a:avLst/>
@@ -13754,8 +13614,8 @@
         </p:nvSpPr>
         <p:spPr>
           <a:xfrm>
-            <a:off x="6126480" y="1842516"/>
-            <a:ext cx="2743200" cy="960120"/>
+            <a:off x="8092440" y="1842516"/>
+            <a:ext cx="3611880" cy="960120"/>
           </a:xfrm>
           <a:prstGeom prst="rect">
             <a:avLst/>
@@ -13799,8 +13659,8 @@
         </p:nvSpPr>
         <p:spPr>
           <a:xfrm>
-            <a:off x="6126480" y="1888236"/>
-            <a:ext cx="2743200" cy="457200"/>
+            <a:off x="8092440" y="1888236"/>
+            <a:ext cx="3611880" cy="457200"/>
           </a:xfrm>
           <a:prstGeom prst="rect">
             <a:avLst/>
@@ -13843,8 +13703,8 @@
         </p:nvSpPr>
         <p:spPr>
           <a:xfrm>
-            <a:off x="6126480" y="2482596"/>
-            <a:ext cx="2743200" cy="274320"/>
+            <a:off x="8092440" y="2482596"/>
+            <a:ext cx="3611880" cy="274320"/>
           </a:xfrm>
           <a:prstGeom prst="rect">
             <a:avLst/>
@@ -13887,8 +13747,8 @@
         </p:nvSpPr>
         <p:spPr>
           <a:xfrm>
-            <a:off x="6126480" y="2802636"/>
-            <a:ext cx="2743200" cy="2880360"/>
+            <a:off x="8092440" y="2802636"/>
+            <a:ext cx="3611880" cy="2880360"/>
           </a:xfrm>
           <a:prstGeom prst="rect">
             <a:avLst/>
@@ -13934,8 +13794,8 @@
         </p:nvSpPr>
         <p:spPr>
           <a:xfrm>
-            <a:off x="6263640" y="2939796"/>
-            <a:ext cx="2468880" cy="365760"/>
+            <a:off x="8273033" y="2939796"/>
+            <a:ext cx="3250692" cy="365760"/>
           </a:xfrm>
           <a:prstGeom prst="rect">
             <a:avLst/>
@@ -13978,8 +13838,8 @@
         </p:nvSpPr>
         <p:spPr>
           <a:xfrm>
-            <a:off x="6263640" y="3351276"/>
-            <a:ext cx="2468880" cy="640080"/>
+            <a:off x="8273033" y="3351276"/>
+            <a:ext cx="3250692" cy="640080"/>
           </a:xfrm>
           <a:prstGeom prst="rect">
             <a:avLst/>
@@ -14022,8 +13882,8 @@
         </p:nvSpPr>
         <p:spPr>
           <a:xfrm>
-            <a:off x="6263640" y="4174236"/>
-            <a:ext cx="2468880" cy="228600"/>
+            <a:off x="8273033" y="4174236"/>
+            <a:ext cx="3250692" cy="228600"/>
           </a:xfrm>
           <a:prstGeom prst="rect">
             <a:avLst/>
@@ -14066,8 +13926,8 @@
         </p:nvSpPr>
         <p:spPr>
           <a:xfrm>
-            <a:off x="6263640" y="4448556"/>
-            <a:ext cx="2468880" cy="365760"/>
+            <a:off x="8273033" y="4448556"/>
+            <a:ext cx="3250692" cy="365760"/>
           </a:xfrm>
           <a:prstGeom prst="rect">
             <a:avLst/>
@@ -14110,8 +13970,8 @@
         </p:nvSpPr>
         <p:spPr>
           <a:xfrm>
-            <a:off x="6263640" y="4814316"/>
-            <a:ext cx="2468880" cy="365760"/>
+            <a:off x="8273033" y="4814316"/>
+            <a:ext cx="3250692" cy="365760"/>
           </a:xfrm>
           <a:prstGeom prst="rect">
             <a:avLst/>
@@ -14154,8 +14014,8 @@
         </p:nvSpPr>
         <p:spPr>
           <a:xfrm>
-            <a:off x="6263640" y="5180076"/>
-            <a:ext cx="2468880" cy="365760"/>
+            <a:off x="8273033" y="5180076"/>
+            <a:ext cx="3250692" cy="365760"/>
           </a:xfrm>
           <a:prstGeom prst="rect">
             <a:avLst/>
@@ -17338,7 +17198,7 @@
         <p:spPr>
           <a:xfrm>
             <a:off x="457200" y="1842516"/>
-            <a:ext cx="2743200" cy="960120"/>
+            <a:ext cx="3611880" cy="960120"/>
           </a:xfrm>
           <a:prstGeom prst="rect">
             <a:avLst/>
@@ -17383,7 +17243,7 @@
         <p:spPr>
           <a:xfrm>
             <a:off x="457200" y="1888236"/>
-            <a:ext cx="2743200" cy="457200"/>
+            <a:ext cx="3611880" cy="457200"/>
           </a:xfrm>
           <a:prstGeom prst="rect">
             <a:avLst/>
@@ -17427,7 +17287,7 @@
         <p:spPr>
           <a:xfrm>
             <a:off x="457200" y="2482596"/>
-            <a:ext cx="2743200" cy="274320"/>
+            <a:ext cx="3611880" cy="274320"/>
           </a:xfrm>
           <a:prstGeom prst="rect">
             <a:avLst/>
@@ -17471,7 +17331,7 @@
         <p:spPr>
           <a:xfrm>
             <a:off x="457200" y="2802636"/>
-            <a:ext cx="2743200" cy="2880360"/>
+            <a:ext cx="3611880" cy="2880360"/>
           </a:xfrm>
           <a:prstGeom prst="rect">
             <a:avLst/>
@@ -17517,8 +17377,8 @@
         </p:nvSpPr>
         <p:spPr>
           <a:xfrm>
-            <a:off x="594360" y="2939796"/>
-            <a:ext cx="2468880" cy="365760"/>
+            <a:off x="637794" y="2939796"/>
+            <a:ext cx="3250692" cy="365760"/>
           </a:xfrm>
           <a:prstGeom prst="rect">
             <a:avLst/>
@@ -17561,8 +17421,8 @@
         </p:nvSpPr>
         <p:spPr>
           <a:xfrm>
-            <a:off x="594360" y="3351276"/>
-            <a:ext cx="2468880" cy="640080"/>
+            <a:off x="637794" y="3351276"/>
+            <a:ext cx="3250692" cy="640080"/>
           </a:xfrm>
           <a:prstGeom prst="rect">
             <a:avLst/>
@@ -17605,8 +17465,8 @@
         </p:nvSpPr>
         <p:spPr>
           <a:xfrm>
-            <a:off x="594360" y="4174236"/>
-            <a:ext cx="2468880" cy="228600"/>
+            <a:off x="637794" y="4174236"/>
+            <a:ext cx="3250692" cy="228600"/>
           </a:xfrm>
           <a:prstGeom prst="rect">
             <a:avLst/>
@@ -17649,8 +17509,8 @@
         </p:nvSpPr>
         <p:spPr>
           <a:xfrm>
-            <a:off x="594360" y="4448556"/>
-            <a:ext cx="2468880" cy="365760"/>
+            <a:off x="637794" y="4448556"/>
+            <a:ext cx="3250692" cy="365760"/>
           </a:xfrm>
           <a:prstGeom prst="rect">
             <a:avLst/>
@@ -17693,8 +17553,8 @@
         </p:nvSpPr>
         <p:spPr>
           <a:xfrm>
-            <a:off x="594360" y="4814316"/>
-            <a:ext cx="2468880" cy="365760"/>
+            <a:off x="637794" y="4814316"/>
+            <a:ext cx="3250692" cy="365760"/>
           </a:xfrm>
           <a:prstGeom prst="rect">
             <a:avLst/>
@@ -17737,8 +17597,8 @@
         </p:nvSpPr>
         <p:spPr>
           <a:xfrm>
-            <a:off x="594360" y="5180076"/>
-            <a:ext cx="2468880" cy="365760"/>
+            <a:off x="637794" y="5180076"/>
+            <a:ext cx="3250692" cy="365760"/>
           </a:xfrm>
           <a:prstGeom prst="rect">
             <a:avLst/>
@@ -17781,8 +17641,8 @@
         </p:nvSpPr>
         <p:spPr>
           <a:xfrm>
-            <a:off x="3291840" y="1842516"/>
-            <a:ext cx="2743200" cy="960120"/>
+            <a:off x="4274820" y="1842516"/>
+            <a:ext cx="3611880" cy="960120"/>
           </a:xfrm>
           <a:prstGeom prst="rect">
             <a:avLst/>
@@ -17826,8 +17686,8 @@
         </p:nvSpPr>
         <p:spPr>
           <a:xfrm>
-            <a:off x="3291840" y="1888236"/>
-            <a:ext cx="2743200" cy="457200"/>
+            <a:off x="4274820" y="1888236"/>
+            <a:ext cx="3611880" cy="457200"/>
           </a:xfrm>
           <a:prstGeom prst="rect">
             <a:avLst/>
@@ -17870,8 +17730,8 @@
         </p:nvSpPr>
         <p:spPr>
           <a:xfrm>
-            <a:off x="3291840" y="2482596"/>
-            <a:ext cx="2743200" cy="274320"/>
+            <a:off x="4274820" y="2482596"/>
+            <a:ext cx="3611880" cy="274320"/>
           </a:xfrm>
           <a:prstGeom prst="rect">
             <a:avLst/>
@@ -17914,8 +17774,8 @@
         </p:nvSpPr>
         <p:spPr>
           <a:xfrm>
-            <a:off x="3291840" y="2802636"/>
-            <a:ext cx="2743200" cy="2880360"/>
+            <a:off x="4274820" y="2802636"/>
+            <a:ext cx="3611880" cy="2880360"/>
           </a:xfrm>
           <a:prstGeom prst="rect">
             <a:avLst/>
@@ -17961,8 +17821,8 @@
         </p:nvSpPr>
         <p:spPr>
           <a:xfrm>
-            <a:off x="3429000" y="2939796"/>
-            <a:ext cx="2468880" cy="365760"/>
+            <a:off x="4455414" y="2939796"/>
+            <a:ext cx="3250692" cy="365760"/>
           </a:xfrm>
           <a:prstGeom prst="rect">
             <a:avLst/>
@@ -18005,8 +17865,8 @@
         </p:nvSpPr>
         <p:spPr>
           <a:xfrm>
-            <a:off x="3429000" y="3351276"/>
-            <a:ext cx="2468880" cy="640080"/>
+            <a:off x="4455414" y="3351276"/>
+            <a:ext cx="3250692" cy="640080"/>
           </a:xfrm>
           <a:prstGeom prst="rect">
             <a:avLst/>
@@ -18049,8 +17909,8 @@
         </p:nvSpPr>
         <p:spPr>
           <a:xfrm>
-            <a:off x="3429000" y="4174236"/>
-            <a:ext cx="2468880" cy="228600"/>
+            <a:off x="4455414" y="4174236"/>
+            <a:ext cx="3250692" cy="228600"/>
           </a:xfrm>
           <a:prstGeom prst="rect">
             <a:avLst/>
@@ -18093,8 +17953,8 @@
         </p:nvSpPr>
         <p:spPr>
           <a:xfrm>
-            <a:off x="3429000" y="4448556"/>
-            <a:ext cx="2468880" cy="365760"/>
+            <a:off x="4455414" y="4448556"/>
+            <a:ext cx="3250692" cy="365760"/>
           </a:xfrm>
           <a:prstGeom prst="rect">
             <a:avLst/>
@@ -18137,8 +17997,8 @@
         </p:nvSpPr>
         <p:spPr>
           <a:xfrm>
-            <a:off x="3429000" y="4814316"/>
-            <a:ext cx="2468880" cy="365760"/>
+            <a:off x="4455414" y="4814316"/>
+            <a:ext cx="3250692" cy="365760"/>
           </a:xfrm>
           <a:prstGeom prst="rect">
             <a:avLst/>
@@ -18181,8 +18041,8 @@
         </p:nvSpPr>
         <p:spPr>
           <a:xfrm>
-            <a:off x="3429000" y="5180076"/>
-            <a:ext cx="2468880" cy="365760"/>
+            <a:off x="4455414" y="5180076"/>
+            <a:ext cx="3250692" cy="365760"/>
           </a:xfrm>
           <a:prstGeom prst="rect">
             <a:avLst/>
@@ -18225,8 +18085,8 @@
         </p:nvSpPr>
         <p:spPr>
           <a:xfrm>
-            <a:off x="6126480" y="1842516"/>
-            <a:ext cx="2743200" cy="960120"/>
+            <a:off x="8092440" y="1842516"/>
+            <a:ext cx="3611880" cy="960120"/>
           </a:xfrm>
           <a:prstGeom prst="rect">
             <a:avLst/>
@@ -18270,8 +18130,8 @@
         </p:nvSpPr>
         <p:spPr>
           <a:xfrm>
-            <a:off x="6126480" y="1888236"/>
-            <a:ext cx="2743200" cy="457200"/>
+            <a:off x="8092440" y="1888236"/>
+            <a:ext cx="3611880" cy="457200"/>
           </a:xfrm>
           <a:prstGeom prst="rect">
             <a:avLst/>
@@ -18314,8 +18174,8 @@
         </p:nvSpPr>
         <p:spPr>
           <a:xfrm>
-            <a:off x="6126480" y="2482596"/>
-            <a:ext cx="2743200" cy="274320"/>
+            <a:off x="8092440" y="2482596"/>
+            <a:ext cx="3611880" cy="274320"/>
           </a:xfrm>
           <a:prstGeom prst="rect">
             <a:avLst/>
@@ -18358,8 +18218,8 @@
         </p:nvSpPr>
         <p:spPr>
           <a:xfrm>
-            <a:off x="6126480" y="2802636"/>
-            <a:ext cx="2743200" cy="2880360"/>
+            <a:off x="8092440" y="2802636"/>
+            <a:ext cx="3611880" cy="2880360"/>
           </a:xfrm>
           <a:prstGeom prst="rect">
             <a:avLst/>
@@ -18405,8 +18265,8 @@
         </p:nvSpPr>
         <p:spPr>
           <a:xfrm>
-            <a:off x="6263640" y="2939796"/>
-            <a:ext cx="2468880" cy="365760"/>
+            <a:off x="8273033" y="2939796"/>
+            <a:ext cx="3250692" cy="365760"/>
           </a:xfrm>
           <a:prstGeom prst="rect">
             <a:avLst/>
@@ -18449,8 +18309,8 @@
         </p:nvSpPr>
         <p:spPr>
           <a:xfrm>
-            <a:off x="6263640" y="3351276"/>
-            <a:ext cx="2468880" cy="640080"/>
+            <a:off x="8273033" y="3351276"/>
+            <a:ext cx="3250692" cy="640080"/>
           </a:xfrm>
           <a:prstGeom prst="rect">
             <a:avLst/>
@@ -18493,8 +18353,8 @@
         </p:nvSpPr>
         <p:spPr>
           <a:xfrm>
-            <a:off x="6263640" y="4174236"/>
-            <a:ext cx="2468880" cy="228600"/>
+            <a:off x="8273033" y="4174236"/>
+            <a:ext cx="3250692" cy="228600"/>
           </a:xfrm>
           <a:prstGeom prst="rect">
             <a:avLst/>
@@ -18537,8 +18397,8 @@
         </p:nvSpPr>
         <p:spPr>
           <a:xfrm>
-            <a:off x="6263640" y="4448556"/>
-            <a:ext cx="2468880" cy="365760"/>
+            <a:off x="8273033" y="4448556"/>
+            <a:ext cx="3250692" cy="365760"/>
           </a:xfrm>
           <a:prstGeom prst="rect">
             <a:avLst/>
@@ -18581,8 +18441,8 @@
         </p:nvSpPr>
         <p:spPr>
           <a:xfrm>
-            <a:off x="6263640" y="4814316"/>
-            <a:ext cx="2468880" cy="365760"/>
+            <a:off x="8273033" y="4814316"/>
+            <a:ext cx="3250692" cy="365760"/>
           </a:xfrm>
           <a:prstGeom prst="rect">
             <a:avLst/>
@@ -18625,8 +18485,8 @@
         </p:nvSpPr>
         <p:spPr>
           <a:xfrm>
-            <a:off x="6263640" y="5180076"/>
-            <a:ext cx="2468880" cy="365760"/>
+            <a:off x="8273033" y="5180076"/>
+            <a:ext cx="3250692" cy="365760"/>
           </a:xfrm>
           <a:prstGeom prst="rect">
             <a:avLst/>

</xml_diff>